<commit_message>
docs: embed speaker notes in fundraising deck
</commit_message>
<xml_diff>
--- a/docs/presentations/2026-03-27-claw-native-commerce-fundraising-deck.pptx
+++ b/docs/presentations/2026-03-27-claw-native-commerce-fundraising-deck.pptx
@@ -511,7 +511,8 @@
           <a:p>
             <a:r>
               <a:rPr lang="en-US" dirty="0"/>
-              <a:t/>
+              <a:t>我们做的不是一个更会推荐商品的电商前台。
+我们要占据的是用户主代理背后的消费交易底座位置。</a:t>
             </a:r>
             <a:endParaRPr lang="en-US" dirty="0"/>
           </a:p>
@@ -599,7 +600,8 @@
           <a:p>
             <a:r>
               <a:rPr lang="en-US" dirty="0"/>
-              <a:t/>
+              <a:t>我们不是在做一个更强的前台，而是在定义 Agent 时代新的交易操作系统。
+Claw Native 想占据的是主代理时代的交易底座位置。</a:t>
             </a:r>
             <a:endParaRPr lang="en-US" dirty="0"/>
           </a:p>
@@ -687,7 +689,8 @@
           <a:p>
             <a:r>
               <a:rPr lang="en-US" dirty="0"/>
-              <a:t/>
+              <a:t>今天购物真正贵的，不是支付动作，而是反复比较和判断的时间与脑力。
+下一代电商的机会，不只是继续优化推荐，而是直接减少用户完成购买任务所需的认知劳动。</a:t>
             </a:r>
             <a:endParaRPr lang="en-US" dirty="0"/>
           </a:p>
@@ -775,7 +778,8 @@
           <a:p>
             <a:r>
               <a:rPr lang="en-US" dirty="0"/>
-              <a:t/>
+              <a:t>过去的入口是 App、搜索和推荐，用户自己完成点击与决策。
+未来用户会先把任务交给 Agent，再由 Agent 决定在哪里买、怎么买、什么时候买。</a:t>
             </a:r>
             <a:endParaRPr lang="en-US" dirty="0"/>
           </a:p>
@@ -863,7 +867,8 @@
           <a:p>
             <a:r>
               <a:rPr lang="en-US" dirty="0"/>
-              <a:t/>
+              <a:t>Claw Native 不是 AI 导购，不是比价工具，也不是会聊天的电商助手。
+我们把购买任务从页面操作流程升级成结构化代理流程，从而重构“怎么买”。</a:t>
             </a:r>
             <a:endParaRPr lang="en-US" dirty="0"/>
           </a:p>
@@ -951,7 +956,8 @@
           <a:p>
             <a:r>
               <a:rPr lang="en-US" dirty="0"/>
-              <a:t/>
+              <a:t>这套系统已经不是概念图，而是能真实演示的最小闭环。
+一端贴近用户真实购物现场，一端验证代理交易后端，二者已经连接起来。</a:t>
             </a:r>
             <a:endParaRPr lang="en-US" dirty="0"/>
           </a:p>
@@ -1039,7 +1045,8 @@
           <a:p>
             <a:r>
               <a:rPr lang="en-US" dirty="0"/>
-              <a:t/>
+              <a:t>重点不是我们有页面，而是系统已经具备 seller 比选、策略判断和 explanation 这些代理式交易的核心步骤。
+从建议到执行，中间不是黑箱，而是一条可回放、可审计的结构化链路。</a:t>
             </a:r>
             <a:endParaRPr lang="en-US" dirty="0"/>
           </a:p>
@@ -1127,7 +1134,8 @@
           <a:p>
             <a:r>
               <a:rPr lang="en-US" dirty="0"/>
-              <a:t/>
+              <a:t>真正的壁垒不是单次回答质量，而是交易编排的位置。
+如果我们占据 buyer-agent-first 的编排层，位置会比单点前台产品深得多。</a:t>
             </a:r>
             <a:endParaRPr lang="en-US" dirty="0"/>
           </a:p>
@@ -1215,7 +1223,8 @@
           <a:p>
             <a:r>
               <a:rPr lang="en-US" dirty="0"/>
-              <a:t/>
+              <a:t>我们不是从大而全开始，而是从最能建立用户信任的高频消费任务切入。
+先验证代理价值，再扩展到更多 category、seller 和协议层。</a:t>
             </a:r>
             <a:endParaRPr lang="en-US" dirty="0"/>
           </a:p>
@@ -1303,7 +1312,8 @@
           <a:p>
             <a:r>
               <a:rPr lang="en-US" dirty="0"/>
-              <a:t/>
+              <a:t>商业模式不会停留在内容流量，而会沿着代理实际替用户完成的交易深度向上走。
+谁掌握交易执行权，谁就掌握长期商业价值。</a:t>
             </a:r>
             <a:endParaRPr lang="en-US" dirty="0"/>
           </a:p>
@@ -1882,7 +1892,7 @@
       </p:sp>
       <p:sp>
         <p:nvSpPr>
-          <p:cNvPr id="8" name="Text 6"/>
+          <p:cNvPr id="9" name="Text 6"/>
           <p:cNvSpPr/>
           <p:nvPr/>
         </p:nvSpPr>
@@ -1921,7 +1931,7 @@
       </p:sp>
       <p:sp>
         <p:nvSpPr>
-          <p:cNvPr id="9" name="Text 7"/>
+          <p:cNvPr id="10" name="Text 7"/>
           <p:cNvSpPr/>
           <p:nvPr/>
         </p:nvSpPr>
@@ -1960,7 +1970,7 @@
       </p:sp>
       <p:sp>
         <p:nvSpPr>
-          <p:cNvPr id="10" name="Text 8"/>
+          <p:cNvPr id="11" name="Text 8"/>
           <p:cNvSpPr/>
           <p:nvPr/>
         </p:nvSpPr>
@@ -1999,7 +2009,7 @@
       </p:sp>
       <p:sp>
         <p:nvSpPr>
-          <p:cNvPr id="11" name="Shape 9"/>
+          <p:cNvPr id="12" name="Shape 9"/>
           <p:cNvSpPr/>
           <p:nvPr/>
         </p:nvSpPr>
@@ -2028,7 +2038,7 @@
       </p:sp>
       <p:sp>
         <p:nvSpPr>
-          <p:cNvPr id="12" name="Text 10"/>
+          <p:cNvPr id="13" name="Text 10"/>
           <p:cNvSpPr/>
           <p:nvPr/>
         </p:nvSpPr>
@@ -2303,7 +2313,7 @@
       </p:sp>
       <p:sp>
         <p:nvSpPr>
-          <p:cNvPr id="8" name="Text 6"/>
+          <p:cNvPr id="9" name="Text 6"/>
           <p:cNvSpPr/>
           <p:nvPr/>
         </p:nvSpPr>
@@ -2342,7 +2352,7 @@
       </p:sp>
       <p:sp>
         <p:nvSpPr>
-          <p:cNvPr id="9" name="Text 7"/>
+          <p:cNvPr id="10" name="Text 7"/>
           <p:cNvSpPr/>
           <p:nvPr/>
         </p:nvSpPr>
@@ -2381,7 +2391,7 @@
       </p:sp>
       <p:sp>
         <p:nvSpPr>
-          <p:cNvPr id="10" name="Shape 8"/>
+          <p:cNvPr id="11" name="Shape 8"/>
           <p:cNvSpPr/>
           <p:nvPr/>
         </p:nvSpPr>
@@ -2408,7 +2418,7 @@
       </p:sp>
       <p:sp>
         <p:nvSpPr>
-          <p:cNvPr id="11" name="Text 9"/>
+          <p:cNvPr id="12" name="Text 9"/>
           <p:cNvSpPr/>
           <p:nvPr/>
         </p:nvSpPr>
@@ -2447,7 +2457,7 @@
       </p:sp>
       <p:sp>
         <p:nvSpPr>
-          <p:cNvPr id="12" name="Text 10"/>
+          <p:cNvPr id="13" name="Text 10"/>
           <p:cNvSpPr/>
           <p:nvPr/>
         </p:nvSpPr>
@@ -2486,7 +2496,7 @@
       </p:sp>
       <p:sp>
         <p:nvSpPr>
-          <p:cNvPr id="13" name="Text 11"/>
+          <p:cNvPr id="14" name="Text 11"/>
           <p:cNvSpPr/>
           <p:nvPr/>
         </p:nvSpPr>
@@ -2525,7 +2535,7 @@
       </p:sp>
       <p:sp>
         <p:nvSpPr>
-          <p:cNvPr id="14" name="Shape 12"/>
+          <p:cNvPr id="15" name="Shape 12"/>
           <p:cNvSpPr/>
           <p:nvPr/>
         </p:nvSpPr>
@@ -2552,7 +2562,7 @@
       </p:sp>
       <p:sp>
         <p:nvSpPr>
-          <p:cNvPr id="15" name="Text 13"/>
+          <p:cNvPr id="16" name="Text 13"/>
           <p:cNvSpPr/>
           <p:nvPr/>
         </p:nvSpPr>
@@ -2591,7 +2601,7 @@
       </p:sp>
       <p:sp>
         <p:nvSpPr>
-          <p:cNvPr id="16" name="Text 14"/>
+          <p:cNvPr id="17" name="Text 14"/>
           <p:cNvSpPr/>
           <p:nvPr/>
         </p:nvSpPr>
@@ -2630,7 +2640,7 @@
       </p:sp>
       <p:sp>
         <p:nvSpPr>
-          <p:cNvPr id="17" name="Text 15"/>
+          <p:cNvPr id="18" name="Text 15"/>
           <p:cNvSpPr/>
           <p:nvPr/>
         </p:nvSpPr>
@@ -2669,7 +2679,7 @@
       </p:sp>
       <p:sp>
         <p:nvSpPr>
-          <p:cNvPr id="18" name="Shape 16"/>
+          <p:cNvPr id="19" name="Shape 16"/>
           <p:cNvSpPr/>
           <p:nvPr/>
         </p:nvSpPr>
@@ -2696,7 +2706,7 @@
       </p:sp>
       <p:sp>
         <p:nvSpPr>
-          <p:cNvPr id="19" name="Text 17"/>
+          <p:cNvPr id="20" name="Text 17"/>
           <p:cNvSpPr/>
           <p:nvPr/>
         </p:nvSpPr>
@@ -2735,7 +2745,7 @@
       </p:sp>
       <p:sp>
         <p:nvSpPr>
-          <p:cNvPr id="20" name="Text 18"/>
+          <p:cNvPr id="21" name="Text 18"/>
           <p:cNvSpPr/>
           <p:nvPr/>
         </p:nvSpPr>
@@ -2774,7 +2784,7 @@
       </p:sp>
       <p:sp>
         <p:nvSpPr>
-          <p:cNvPr id="21" name="Text 19"/>
+          <p:cNvPr id="22" name="Text 19"/>
           <p:cNvSpPr/>
           <p:nvPr/>
         </p:nvSpPr>
@@ -2813,7 +2823,7 @@
       </p:sp>
       <p:sp>
         <p:nvSpPr>
-          <p:cNvPr id="22" name="Shape 20"/>
+          <p:cNvPr id="23" name="Shape 20"/>
           <p:cNvSpPr/>
           <p:nvPr/>
         </p:nvSpPr>
@@ -2842,7 +2852,7 @@
       </p:sp>
       <p:sp>
         <p:nvSpPr>
-          <p:cNvPr id="23" name="Text 21"/>
+          <p:cNvPr id="24" name="Text 21"/>
           <p:cNvSpPr/>
           <p:nvPr/>
         </p:nvSpPr>
@@ -3098,7 +3108,7 @@
       </p:sp>
       <p:sp>
         <p:nvSpPr>
-          <p:cNvPr id="7" name="Text 5"/>
+          <p:cNvPr id="8" name="Text 5"/>
           <p:cNvSpPr/>
           <p:nvPr/>
         </p:nvSpPr>
@@ -3137,7 +3147,7 @@
       </p:sp>
       <p:sp>
         <p:nvSpPr>
-          <p:cNvPr id="8" name="Text 6"/>
+          <p:cNvPr id="9" name="Text 6"/>
           <p:cNvSpPr/>
           <p:nvPr/>
         </p:nvSpPr>
@@ -3176,7 +3186,7 @@
       </p:sp>
       <p:sp>
         <p:nvSpPr>
-          <p:cNvPr id="9" name="Text 7"/>
+          <p:cNvPr id="10" name="Text 7"/>
           <p:cNvSpPr/>
           <p:nvPr/>
         </p:nvSpPr>
@@ -3215,7 +3225,7 @@
       </p:sp>
       <p:sp>
         <p:nvSpPr>
-          <p:cNvPr id="10" name="Text 8"/>
+          <p:cNvPr id="11" name="Text 8"/>
           <p:cNvSpPr/>
           <p:nvPr/>
         </p:nvSpPr>
@@ -3254,7 +3264,7 @@
       </p:sp>
       <p:sp>
         <p:nvSpPr>
-          <p:cNvPr id="11" name="Text 9"/>
+          <p:cNvPr id="12" name="Text 9"/>
           <p:cNvSpPr/>
           <p:nvPr/>
         </p:nvSpPr>
@@ -3330,7 +3340,7 @@
       </p:sp>
       <p:sp>
         <p:nvSpPr>
-          <p:cNvPr id="12" name="Text 10"/>
+          <p:cNvPr id="13" name="Text 10"/>
           <p:cNvSpPr/>
           <p:nvPr/>
         </p:nvSpPr>
@@ -3369,7 +3379,7 @@
       </p:sp>
       <p:sp>
         <p:nvSpPr>
-          <p:cNvPr id="13" name="Shape 11"/>
+          <p:cNvPr id="14" name="Shape 11"/>
           <p:cNvSpPr/>
           <p:nvPr/>
         </p:nvSpPr>
@@ -3396,7 +3406,7 @@
       </p:sp>
       <p:sp>
         <p:nvSpPr>
-          <p:cNvPr id="14" name="Text 12"/>
+          <p:cNvPr id="15" name="Text 12"/>
           <p:cNvSpPr/>
           <p:nvPr/>
         </p:nvSpPr>
@@ -3435,7 +3445,7 @@
       </p:sp>
       <p:sp>
         <p:nvSpPr>
-          <p:cNvPr id="15" name="Text 13"/>
+          <p:cNvPr id="16" name="Text 13"/>
           <p:cNvSpPr/>
           <p:nvPr/>
         </p:nvSpPr>
@@ -3474,7 +3484,7 @@
       </p:sp>
       <p:sp>
         <p:nvSpPr>
-          <p:cNvPr id="16" name="Shape 14"/>
+          <p:cNvPr id="17" name="Shape 14"/>
           <p:cNvSpPr/>
           <p:nvPr/>
         </p:nvSpPr>
@@ -3501,7 +3511,7 @@
       </p:sp>
       <p:sp>
         <p:nvSpPr>
-          <p:cNvPr id="17" name="Text 15"/>
+          <p:cNvPr id="18" name="Text 15"/>
           <p:cNvSpPr/>
           <p:nvPr/>
         </p:nvSpPr>
@@ -3540,7 +3550,7 @@
       </p:sp>
       <p:sp>
         <p:nvSpPr>
-          <p:cNvPr id="18" name="Text 16"/>
+          <p:cNvPr id="19" name="Text 16"/>
           <p:cNvSpPr/>
           <p:nvPr/>
         </p:nvSpPr>
@@ -3579,7 +3589,7 @@
       </p:sp>
       <p:sp>
         <p:nvSpPr>
-          <p:cNvPr id="19" name="Shape 17"/>
+          <p:cNvPr id="20" name="Shape 17"/>
           <p:cNvSpPr/>
           <p:nvPr/>
         </p:nvSpPr>
@@ -3606,7 +3616,7 @@
       </p:sp>
       <p:sp>
         <p:nvSpPr>
-          <p:cNvPr id="20" name="Text 18"/>
+          <p:cNvPr id="21" name="Text 18"/>
           <p:cNvSpPr/>
           <p:nvPr/>
         </p:nvSpPr>
@@ -3645,7 +3655,7 @@
       </p:sp>
       <p:sp>
         <p:nvSpPr>
-          <p:cNvPr id="21" name="Text 19"/>
+          <p:cNvPr id="22" name="Text 19"/>
           <p:cNvSpPr/>
           <p:nvPr/>
         </p:nvSpPr>
@@ -3684,7 +3694,7 @@
       </p:sp>
       <p:sp>
         <p:nvSpPr>
-          <p:cNvPr id="22" name="Shape 20"/>
+          <p:cNvPr id="23" name="Shape 20"/>
           <p:cNvSpPr/>
           <p:nvPr/>
         </p:nvSpPr>
@@ -3713,7 +3723,7 @@
       </p:sp>
       <p:sp>
         <p:nvSpPr>
-          <p:cNvPr id="23" name="Text 21"/>
+          <p:cNvPr id="24" name="Text 21"/>
           <p:cNvSpPr/>
           <p:nvPr/>
         </p:nvSpPr>
@@ -3752,7 +3762,7 @@
       </p:sp>
       <p:sp>
         <p:nvSpPr>
-          <p:cNvPr id="24" name="Text 22"/>
+          <p:cNvPr id="25" name="Text 22"/>
           <p:cNvSpPr/>
           <p:nvPr/>
         </p:nvSpPr>
@@ -4008,7 +4018,7 @@
       </p:sp>
       <p:sp>
         <p:nvSpPr>
-          <p:cNvPr id="7" name="Text 5"/>
+          <p:cNvPr id="8" name="Text 5"/>
           <p:cNvSpPr/>
           <p:nvPr/>
         </p:nvSpPr>
@@ -4047,7 +4057,7 @@
       </p:sp>
       <p:sp>
         <p:nvSpPr>
-          <p:cNvPr id="8" name="Text 6"/>
+          <p:cNvPr id="9" name="Text 6"/>
           <p:cNvSpPr/>
           <p:nvPr/>
         </p:nvSpPr>
@@ -4086,7 +4096,7 @@
       </p:sp>
       <p:sp>
         <p:nvSpPr>
-          <p:cNvPr id="9" name="Shape 7"/>
+          <p:cNvPr id="10" name="Shape 7"/>
           <p:cNvSpPr/>
           <p:nvPr/>
         </p:nvSpPr>
@@ -4113,7 +4123,7 @@
       </p:sp>
       <p:sp>
         <p:nvSpPr>
-          <p:cNvPr id="10" name="Text 8"/>
+          <p:cNvPr id="11" name="Text 8"/>
           <p:cNvSpPr/>
           <p:nvPr/>
         </p:nvSpPr>
@@ -4152,7 +4162,7 @@
       </p:sp>
       <p:sp>
         <p:nvSpPr>
-          <p:cNvPr id="11" name="Text 9"/>
+          <p:cNvPr id="12" name="Text 9"/>
           <p:cNvSpPr/>
           <p:nvPr/>
         </p:nvSpPr>
@@ -4191,7 +4201,7 @@
       </p:sp>
       <p:sp>
         <p:nvSpPr>
-          <p:cNvPr id="12" name="Text 10"/>
+          <p:cNvPr id="13" name="Text 10"/>
           <p:cNvSpPr/>
           <p:nvPr/>
         </p:nvSpPr>
@@ -4281,7 +4291,7 @@
       </p:sp>
       <p:sp>
         <p:nvSpPr>
-          <p:cNvPr id="13" name="Shape 11"/>
+          <p:cNvPr id="14" name="Shape 11"/>
           <p:cNvSpPr/>
           <p:nvPr/>
         </p:nvSpPr>
@@ -4308,7 +4318,7 @@
       </p:sp>
       <p:sp>
         <p:nvSpPr>
-          <p:cNvPr id="14" name="Text 12"/>
+          <p:cNvPr id="15" name="Text 12"/>
           <p:cNvSpPr/>
           <p:nvPr/>
         </p:nvSpPr>
@@ -4347,7 +4357,7 @@
       </p:sp>
       <p:sp>
         <p:nvSpPr>
-          <p:cNvPr id="15" name="Text 13"/>
+          <p:cNvPr id="16" name="Text 13"/>
           <p:cNvSpPr/>
           <p:nvPr/>
         </p:nvSpPr>
@@ -4386,7 +4396,7 @@
       </p:sp>
       <p:sp>
         <p:nvSpPr>
-          <p:cNvPr id="16" name="Text 14"/>
+          <p:cNvPr id="17" name="Text 14"/>
           <p:cNvSpPr/>
           <p:nvPr/>
         </p:nvSpPr>
@@ -4476,7 +4486,7 @@
       </p:sp>
       <p:sp>
         <p:nvSpPr>
-          <p:cNvPr id="17" name="Shape 15"/>
+          <p:cNvPr id="18" name="Shape 15"/>
           <p:cNvSpPr/>
           <p:nvPr/>
         </p:nvSpPr>
@@ -4505,7 +4515,7 @@
       </p:sp>
       <p:sp>
         <p:nvSpPr>
-          <p:cNvPr id="18" name="Text 16"/>
+          <p:cNvPr id="19" name="Text 16"/>
           <p:cNvSpPr/>
           <p:nvPr/>
         </p:nvSpPr>
@@ -4761,7 +4771,7 @@
       </p:sp>
       <p:sp>
         <p:nvSpPr>
-          <p:cNvPr id="7" name="Text 5"/>
+          <p:cNvPr id="8" name="Text 5"/>
           <p:cNvSpPr/>
           <p:nvPr/>
         </p:nvSpPr>
@@ -4800,7 +4810,7 @@
       </p:sp>
       <p:sp>
         <p:nvSpPr>
-          <p:cNvPr id="8" name="Text 6"/>
+          <p:cNvPr id="9" name="Text 6"/>
           <p:cNvSpPr/>
           <p:nvPr/>
         </p:nvSpPr>
@@ -4839,7 +4849,7 @@
       </p:sp>
       <p:sp>
         <p:nvSpPr>
-          <p:cNvPr id="9" name="Shape 7"/>
+          <p:cNvPr id="10" name="Shape 7"/>
           <p:cNvSpPr/>
           <p:nvPr/>
         </p:nvSpPr>
@@ -4866,7 +4876,7 @@
       </p:sp>
       <p:sp>
         <p:nvSpPr>
-          <p:cNvPr id="10" name="Text 8"/>
+          <p:cNvPr id="11" name="Text 8"/>
           <p:cNvSpPr/>
           <p:nvPr/>
         </p:nvSpPr>
@@ -4905,7 +4915,7 @@
       </p:sp>
       <p:sp>
         <p:nvSpPr>
-          <p:cNvPr id="11" name="Shape 9"/>
+          <p:cNvPr id="12" name="Shape 9"/>
           <p:cNvSpPr/>
           <p:nvPr/>
         </p:nvSpPr>
@@ -4930,7 +4940,7 @@
       </p:sp>
       <p:sp>
         <p:nvSpPr>
-          <p:cNvPr id="12" name="Shape 10"/>
+          <p:cNvPr id="13" name="Shape 10"/>
           <p:cNvSpPr/>
           <p:nvPr/>
         </p:nvSpPr>
@@ -4957,7 +4967,7 @@
       </p:sp>
       <p:sp>
         <p:nvSpPr>
-          <p:cNvPr id="13" name="Text 11"/>
+          <p:cNvPr id="14" name="Text 11"/>
           <p:cNvSpPr/>
           <p:nvPr/>
         </p:nvSpPr>
@@ -4996,7 +5006,7 @@
       </p:sp>
       <p:sp>
         <p:nvSpPr>
-          <p:cNvPr id="14" name="Shape 12"/>
+          <p:cNvPr id="15" name="Shape 12"/>
           <p:cNvSpPr/>
           <p:nvPr/>
         </p:nvSpPr>
@@ -5021,7 +5031,7 @@
       </p:sp>
       <p:sp>
         <p:nvSpPr>
-          <p:cNvPr id="15" name="Shape 13"/>
+          <p:cNvPr id="16" name="Shape 13"/>
           <p:cNvSpPr/>
           <p:nvPr/>
         </p:nvSpPr>
@@ -5048,7 +5058,7 @@
       </p:sp>
       <p:sp>
         <p:nvSpPr>
-          <p:cNvPr id="16" name="Text 14"/>
+          <p:cNvPr id="17" name="Text 14"/>
           <p:cNvSpPr/>
           <p:nvPr/>
         </p:nvSpPr>
@@ -5087,7 +5097,7 @@
       </p:sp>
       <p:sp>
         <p:nvSpPr>
-          <p:cNvPr id="17" name="Shape 15"/>
+          <p:cNvPr id="18" name="Shape 15"/>
           <p:cNvSpPr/>
           <p:nvPr/>
         </p:nvSpPr>
@@ -5112,7 +5122,7 @@
       </p:sp>
       <p:sp>
         <p:nvSpPr>
-          <p:cNvPr id="18" name="Shape 16"/>
+          <p:cNvPr id="19" name="Shape 16"/>
           <p:cNvSpPr/>
           <p:nvPr/>
         </p:nvSpPr>
@@ -5139,7 +5149,7 @@
       </p:sp>
       <p:sp>
         <p:nvSpPr>
-          <p:cNvPr id="19" name="Text 17"/>
+          <p:cNvPr id="20" name="Text 17"/>
           <p:cNvSpPr/>
           <p:nvPr/>
         </p:nvSpPr>
@@ -5178,7 +5188,7 @@
       </p:sp>
       <p:sp>
         <p:nvSpPr>
-          <p:cNvPr id="20" name="Shape 18"/>
+          <p:cNvPr id="21" name="Shape 18"/>
           <p:cNvSpPr/>
           <p:nvPr/>
         </p:nvSpPr>
@@ -5203,7 +5213,7 @@
       </p:sp>
       <p:sp>
         <p:nvSpPr>
-          <p:cNvPr id="21" name="Shape 19"/>
+          <p:cNvPr id="22" name="Shape 19"/>
           <p:cNvSpPr/>
           <p:nvPr/>
         </p:nvSpPr>
@@ -5230,7 +5240,7 @@
       </p:sp>
       <p:sp>
         <p:nvSpPr>
-          <p:cNvPr id="22" name="Text 20"/>
+          <p:cNvPr id="23" name="Text 20"/>
           <p:cNvSpPr/>
           <p:nvPr/>
         </p:nvSpPr>
@@ -5269,7 +5279,7 @@
       </p:sp>
       <p:sp>
         <p:nvSpPr>
-          <p:cNvPr id="23" name="Shape 21"/>
+          <p:cNvPr id="24" name="Shape 21"/>
           <p:cNvSpPr/>
           <p:nvPr/>
         </p:nvSpPr>
@@ -5294,7 +5304,7 @@
       </p:sp>
       <p:sp>
         <p:nvSpPr>
-          <p:cNvPr id="24" name="Shape 22"/>
+          <p:cNvPr id="25" name="Shape 22"/>
           <p:cNvSpPr/>
           <p:nvPr/>
         </p:nvSpPr>
@@ -5321,7 +5331,7 @@
       </p:sp>
       <p:sp>
         <p:nvSpPr>
-          <p:cNvPr id="25" name="Text 23"/>
+          <p:cNvPr id="26" name="Text 23"/>
           <p:cNvSpPr/>
           <p:nvPr/>
         </p:nvSpPr>
@@ -5360,7 +5370,7 @@
       </p:sp>
       <p:sp>
         <p:nvSpPr>
-          <p:cNvPr id="26" name="Shape 24"/>
+          <p:cNvPr id="27" name="Shape 24"/>
           <p:cNvSpPr/>
           <p:nvPr/>
         </p:nvSpPr>
@@ -5387,7 +5397,7 @@
       </p:sp>
       <p:sp>
         <p:nvSpPr>
-          <p:cNvPr id="27" name="Text 25"/>
+          <p:cNvPr id="28" name="Text 25"/>
           <p:cNvSpPr/>
           <p:nvPr/>
         </p:nvSpPr>
@@ -5426,7 +5436,7 @@
       </p:sp>
       <p:sp>
         <p:nvSpPr>
-          <p:cNvPr id="28" name="Text 26"/>
+          <p:cNvPr id="29" name="Text 26"/>
           <p:cNvSpPr/>
           <p:nvPr/>
         </p:nvSpPr>
@@ -5465,7 +5475,7 @@
       </p:sp>
       <p:sp>
         <p:nvSpPr>
-          <p:cNvPr id="29" name="Shape 27"/>
+          <p:cNvPr id="30" name="Shape 27"/>
           <p:cNvSpPr/>
           <p:nvPr/>
         </p:nvSpPr>
@@ -5492,7 +5502,7 @@
       </p:sp>
       <p:sp>
         <p:nvSpPr>
-          <p:cNvPr id="30" name="Text 28"/>
+          <p:cNvPr id="31" name="Text 28"/>
           <p:cNvSpPr/>
           <p:nvPr/>
         </p:nvSpPr>
@@ -5531,7 +5541,7 @@
       </p:sp>
       <p:sp>
         <p:nvSpPr>
-          <p:cNvPr id="31" name="Text 29"/>
+          <p:cNvPr id="32" name="Text 29"/>
           <p:cNvSpPr/>
           <p:nvPr/>
         </p:nvSpPr>
@@ -5570,7 +5580,7 @@
       </p:sp>
       <p:sp>
         <p:nvSpPr>
-          <p:cNvPr id="32" name="Shape 30"/>
+          <p:cNvPr id="33" name="Shape 30"/>
           <p:cNvSpPr/>
           <p:nvPr/>
         </p:nvSpPr>
@@ -5597,7 +5607,7 @@
       </p:sp>
       <p:sp>
         <p:nvSpPr>
-          <p:cNvPr id="33" name="Text 31"/>
+          <p:cNvPr id="34" name="Text 31"/>
           <p:cNvSpPr/>
           <p:nvPr/>
         </p:nvSpPr>
@@ -5636,7 +5646,7 @@
       </p:sp>
       <p:sp>
         <p:nvSpPr>
-          <p:cNvPr id="34" name="Text 32"/>
+          <p:cNvPr id="35" name="Text 32"/>
           <p:cNvSpPr/>
           <p:nvPr/>
         </p:nvSpPr>
@@ -5892,7 +5902,7 @@
       </p:sp>
       <p:sp>
         <p:nvSpPr>
-          <p:cNvPr id="7" name="Text 5"/>
+          <p:cNvPr id="8" name="Text 5"/>
           <p:cNvSpPr/>
           <p:nvPr/>
         </p:nvSpPr>
@@ -5931,7 +5941,7 @@
       </p:sp>
       <p:sp>
         <p:nvSpPr>
-          <p:cNvPr id="8" name="Text 6"/>
+          <p:cNvPr id="9" name="Text 6"/>
           <p:cNvSpPr/>
           <p:nvPr/>
         </p:nvSpPr>
@@ -5970,7 +5980,7 @@
       </p:sp>
       <p:sp>
         <p:nvSpPr>
-          <p:cNvPr id="9" name="Shape 7"/>
+          <p:cNvPr id="10" name="Shape 7"/>
           <p:cNvSpPr/>
           <p:nvPr/>
         </p:nvSpPr>
@@ -5997,7 +6007,7 @@
       </p:sp>
       <p:sp>
         <p:nvSpPr>
-          <p:cNvPr id="10" name="Shape 8"/>
+          <p:cNvPr id="11" name="Shape 8"/>
           <p:cNvSpPr/>
           <p:nvPr/>
         </p:nvSpPr>
@@ -6026,7 +6036,7 @@
       </p:sp>
       <p:sp>
         <p:nvSpPr>
-          <p:cNvPr id="11" name="Text 9"/>
+          <p:cNvPr id="12" name="Text 9"/>
           <p:cNvSpPr/>
           <p:nvPr/>
         </p:nvSpPr>
@@ -6065,7 +6075,7 @@
       </p:sp>
       <p:sp>
         <p:nvSpPr>
-          <p:cNvPr id="12" name="Shape 10"/>
+          <p:cNvPr id="13" name="Shape 10"/>
           <p:cNvSpPr/>
           <p:nvPr/>
         </p:nvSpPr>
@@ -6092,7 +6102,7 @@
       </p:sp>
       <p:sp>
         <p:nvSpPr>
-          <p:cNvPr id="13" name="Text 11"/>
+          <p:cNvPr id="14" name="Text 11"/>
           <p:cNvSpPr/>
           <p:nvPr/>
         </p:nvSpPr>
@@ -6131,7 +6141,7 @@
       </p:sp>
       <p:sp>
         <p:nvSpPr>
-          <p:cNvPr id="14" name="Shape 12"/>
+          <p:cNvPr id="15" name="Shape 12"/>
           <p:cNvSpPr/>
           <p:nvPr/>
         </p:nvSpPr>
@@ -6158,7 +6168,7 @@
       </p:sp>
       <p:sp>
         <p:nvSpPr>
-          <p:cNvPr id="15" name="Text 13"/>
+          <p:cNvPr id="16" name="Text 13"/>
           <p:cNvSpPr/>
           <p:nvPr/>
         </p:nvSpPr>
@@ -6197,7 +6207,7 @@
       </p:sp>
       <p:sp>
         <p:nvSpPr>
-          <p:cNvPr id="16" name="Shape 14"/>
+          <p:cNvPr id="17" name="Shape 14"/>
           <p:cNvSpPr/>
           <p:nvPr/>
         </p:nvSpPr>
@@ -6224,7 +6234,7 @@
       </p:sp>
       <p:sp>
         <p:nvSpPr>
-          <p:cNvPr id="17" name="Text 15"/>
+          <p:cNvPr id="18" name="Text 15"/>
           <p:cNvSpPr/>
           <p:nvPr/>
         </p:nvSpPr>
@@ -6263,7 +6273,7 @@
       </p:sp>
       <p:sp>
         <p:nvSpPr>
-          <p:cNvPr id="18" name="Shape 16"/>
+          <p:cNvPr id="19" name="Shape 16"/>
           <p:cNvSpPr/>
           <p:nvPr/>
         </p:nvSpPr>
@@ -6290,7 +6300,7 @@
       </p:sp>
       <p:sp>
         <p:nvSpPr>
-          <p:cNvPr id="19" name="Text 17"/>
+          <p:cNvPr id="20" name="Text 17"/>
           <p:cNvSpPr/>
           <p:nvPr/>
         </p:nvSpPr>
@@ -6329,7 +6339,7 @@
       </p:sp>
       <p:sp>
         <p:nvSpPr>
-          <p:cNvPr id="20" name="Shape 18"/>
+          <p:cNvPr id="21" name="Shape 18"/>
           <p:cNvSpPr/>
           <p:nvPr/>
         </p:nvSpPr>
@@ -6356,7 +6366,7 @@
       </p:sp>
       <p:sp>
         <p:nvSpPr>
-          <p:cNvPr id="21" name="Shape 19"/>
+          <p:cNvPr id="22" name="Shape 19"/>
           <p:cNvSpPr/>
           <p:nvPr/>
         </p:nvSpPr>
@@ -6385,7 +6395,7 @@
       </p:sp>
       <p:sp>
         <p:nvSpPr>
-          <p:cNvPr id="22" name="Text 20"/>
+          <p:cNvPr id="23" name="Text 20"/>
           <p:cNvSpPr/>
           <p:nvPr/>
         </p:nvSpPr>
@@ -6424,7 +6434,7 @@
       </p:sp>
       <p:sp>
         <p:nvSpPr>
-          <p:cNvPr id="23" name="Shape 21"/>
+          <p:cNvPr id="24" name="Shape 21"/>
           <p:cNvSpPr/>
           <p:nvPr/>
         </p:nvSpPr>
@@ -6451,7 +6461,7 @@
       </p:sp>
       <p:sp>
         <p:nvSpPr>
-          <p:cNvPr id="24" name="Text 22"/>
+          <p:cNvPr id="25" name="Text 22"/>
           <p:cNvSpPr/>
           <p:nvPr/>
         </p:nvSpPr>
@@ -6490,7 +6500,7 @@
       </p:sp>
       <p:sp>
         <p:nvSpPr>
-          <p:cNvPr id="25" name="Shape 23"/>
+          <p:cNvPr id="26" name="Shape 23"/>
           <p:cNvSpPr/>
           <p:nvPr/>
         </p:nvSpPr>
@@ -6517,7 +6527,7 @@
       </p:sp>
       <p:sp>
         <p:nvSpPr>
-          <p:cNvPr id="26" name="Text 24"/>
+          <p:cNvPr id="27" name="Text 24"/>
           <p:cNvSpPr/>
           <p:nvPr/>
         </p:nvSpPr>
@@ -6556,7 +6566,7 @@
       </p:sp>
       <p:sp>
         <p:nvSpPr>
-          <p:cNvPr id="27" name="Shape 25"/>
+          <p:cNvPr id="28" name="Shape 25"/>
           <p:cNvSpPr/>
           <p:nvPr/>
         </p:nvSpPr>
@@ -6583,7 +6593,7 @@
       </p:sp>
       <p:sp>
         <p:nvSpPr>
-          <p:cNvPr id="28" name="Text 26"/>
+          <p:cNvPr id="29" name="Text 26"/>
           <p:cNvSpPr/>
           <p:nvPr/>
         </p:nvSpPr>
@@ -6622,7 +6632,7 @@
       </p:sp>
       <p:sp>
         <p:nvSpPr>
-          <p:cNvPr id="29" name="Shape 27"/>
+          <p:cNvPr id="30" name="Shape 27"/>
           <p:cNvSpPr/>
           <p:nvPr/>
         </p:nvSpPr>
@@ -6649,7 +6659,7 @@
       </p:sp>
       <p:sp>
         <p:nvSpPr>
-          <p:cNvPr id="30" name="Text 28"/>
+          <p:cNvPr id="31" name="Text 28"/>
           <p:cNvSpPr/>
           <p:nvPr/>
         </p:nvSpPr>
@@ -6688,7 +6698,7 @@
       </p:sp>
       <p:sp>
         <p:nvSpPr>
-          <p:cNvPr id="31" name="Shape 29"/>
+          <p:cNvPr id="32" name="Shape 29"/>
           <p:cNvSpPr/>
           <p:nvPr/>
         </p:nvSpPr>
@@ -6715,7 +6725,7 @@
       </p:sp>
       <p:sp>
         <p:nvSpPr>
-          <p:cNvPr id="32" name="Text 30"/>
+          <p:cNvPr id="33" name="Text 30"/>
           <p:cNvSpPr/>
           <p:nvPr/>
         </p:nvSpPr>
@@ -6754,7 +6764,7 @@
       </p:sp>
       <p:sp>
         <p:nvSpPr>
-          <p:cNvPr id="33" name="Text 31"/>
+          <p:cNvPr id="34" name="Text 31"/>
           <p:cNvSpPr/>
           <p:nvPr/>
         </p:nvSpPr>
@@ -6793,7 +6803,7 @@
       </p:sp>
       <p:sp>
         <p:nvSpPr>
-          <p:cNvPr id="34" name="Text 32"/>
+          <p:cNvPr id="35" name="Text 32"/>
           <p:cNvSpPr/>
           <p:nvPr/>
         </p:nvSpPr>
@@ -6832,7 +6842,7 @@
       </p:sp>
       <p:sp>
         <p:nvSpPr>
-          <p:cNvPr id="35" name="Shape 33"/>
+          <p:cNvPr id="36" name="Shape 33"/>
           <p:cNvSpPr/>
           <p:nvPr/>
         </p:nvSpPr>
@@ -6859,7 +6869,7 @@
       </p:sp>
       <p:sp>
         <p:nvSpPr>
-          <p:cNvPr id="36" name="Text 34"/>
+          <p:cNvPr id="37" name="Text 34"/>
           <p:cNvSpPr/>
           <p:nvPr/>
         </p:nvSpPr>
@@ -6898,7 +6908,7 @@
       </p:sp>
       <p:sp>
         <p:nvSpPr>
-          <p:cNvPr id="37" name="Text 35"/>
+          <p:cNvPr id="38" name="Text 35"/>
           <p:cNvSpPr/>
           <p:nvPr/>
         </p:nvSpPr>
@@ -6937,7 +6947,7 @@
       </p:sp>
       <p:sp>
         <p:nvSpPr>
-          <p:cNvPr id="38" name="Text 36"/>
+          <p:cNvPr id="39" name="Text 36"/>
           <p:cNvSpPr/>
           <p:nvPr/>
         </p:nvSpPr>
@@ -6976,7 +6986,7 @@
       </p:sp>
       <p:sp>
         <p:nvSpPr>
-          <p:cNvPr id="39" name="Shape 37"/>
+          <p:cNvPr id="40" name="Shape 37"/>
           <p:cNvSpPr/>
           <p:nvPr/>
         </p:nvSpPr>
@@ -7003,7 +7013,7 @@
       </p:sp>
       <p:sp>
         <p:nvSpPr>
-          <p:cNvPr id="40" name="Text 38"/>
+          <p:cNvPr id="41" name="Text 38"/>
           <p:cNvSpPr/>
           <p:nvPr/>
         </p:nvSpPr>
@@ -7042,7 +7052,7 @@
       </p:sp>
       <p:sp>
         <p:nvSpPr>
-          <p:cNvPr id="41" name="Text 39"/>
+          <p:cNvPr id="42" name="Text 39"/>
           <p:cNvSpPr/>
           <p:nvPr/>
         </p:nvSpPr>
@@ -7081,7 +7091,7 @@
       </p:sp>
       <p:sp>
         <p:nvSpPr>
-          <p:cNvPr id="42" name="Text 40"/>
+          <p:cNvPr id="43" name="Text 40"/>
           <p:cNvSpPr/>
           <p:nvPr/>
         </p:nvSpPr>
@@ -7337,7 +7347,7 @@
       </p:sp>
       <p:sp>
         <p:nvSpPr>
-          <p:cNvPr id="7" name="Text 5"/>
+          <p:cNvPr id="8" name="Text 5"/>
           <p:cNvSpPr/>
           <p:nvPr/>
         </p:nvSpPr>
@@ -7376,7 +7386,7 @@
       </p:sp>
       <p:sp>
         <p:nvSpPr>
-          <p:cNvPr id="8" name="Text 6"/>
+          <p:cNvPr id="9" name="Text 6"/>
           <p:cNvSpPr/>
           <p:nvPr/>
         </p:nvSpPr>
@@ -7415,7 +7425,7 @@
       </p:sp>
       <p:sp>
         <p:nvSpPr>
-          <p:cNvPr id="9" name="Shape 7"/>
+          <p:cNvPr id="10" name="Shape 7"/>
           <p:cNvSpPr/>
           <p:nvPr/>
         </p:nvSpPr>
@@ -7442,7 +7452,7 @@
       </p:sp>
       <p:sp>
         <p:nvSpPr>
-          <p:cNvPr id="10" name="Text 8"/>
+          <p:cNvPr id="11" name="Text 8"/>
           <p:cNvSpPr/>
           <p:nvPr/>
         </p:nvSpPr>
@@ -7481,7 +7491,7 @@
       </p:sp>
       <p:sp>
         <p:nvSpPr>
-          <p:cNvPr id="11" name="Shape 9"/>
+          <p:cNvPr id="12" name="Shape 9"/>
           <p:cNvSpPr/>
           <p:nvPr/>
         </p:nvSpPr>
@@ -7506,7 +7516,7 @@
       </p:sp>
       <p:sp>
         <p:nvSpPr>
-          <p:cNvPr id="12" name="Shape 10"/>
+          <p:cNvPr id="13" name="Shape 10"/>
           <p:cNvSpPr/>
           <p:nvPr/>
         </p:nvSpPr>
@@ -7533,7 +7543,7 @@
       </p:sp>
       <p:sp>
         <p:nvSpPr>
-          <p:cNvPr id="13" name="Text 11"/>
+          <p:cNvPr id="14" name="Text 11"/>
           <p:cNvSpPr/>
           <p:nvPr/>
         </p:nvSpPr>
@@ -7572,7 +7582,7 @@
       </p:sp>
       <p:sp>
         <p:nvSpPr>
-          <p:cNvPr id="14" name="Shape 12"/>
+          <p:cNvPr id="15" name="Shape 12"/>
           <p:cNvSpPr/>
           <p:nvPr/>
         </p:nvSpPr>
@@ -7597,7 +7607,7 @@
       </p:sp>
       <p:sp>
         <p:nvSpPr>
-          <p:cNvPr id="15" name="Shape 13"/>
+          <p:cNvPr id="16" name="Shape 13"/>
           <p:cNvSpPr/>
           <p:nvPr/>
         </p:nvSpPr>
@@ -7624,7 +7634,7 @@
       </p:sp>
       <p:sp>
         <p:nvSpPr>
-          <p:cNvPr id="16" name="Text 14"/>
+          <p:cNvPr id="17" name="Text 14"/>
           <p:cNvSpPr/>
           <p:nvPr/>
         </p:nvSpPr>
@@ -7663,7 +7673,7 @@
       </p:sp>
       <p:sp>
         <p:nvSpPr>
-          <p:cNvPr id="17" name="Shape 15"/>
+          <p:cNvPr id="18" name="Shape 15"/>
           <p:cNvSpPr/>
           <p:nvPr/>
         </p:nvSpPr>
@@ -7688,7 +7698,7 @@
       </p:sp>
       <p:sp>
         <p:nvSpPr>
-          <p:cNvPr id="18" name="Shape 16"/>
+          <p:cNvPr id="19" name="Shape 16"/>
           <p:cNvSpPr/>
           <p:nvPr/>
         </p:nvSpPr>
@@ -7715,7 +7725,7 @@
       </p:sp>
       <p:sp>
         <p:nvSpPr>
-          <p:cNvPr id="19" name="Text 17"/>
+          <p:cNvPr id="20" name="Text 17"/>
           <p:cNvSpPr/>
           <p:nvPr/>
         </p:nvSpPr>
@@ -7754,7 +7764,7 @@
       </p:sp>
       <p:sp>
         <p:nvSpPr>
-          <p:cNvPr id="20" name="Shape 18"/>
+          <p:cNvPr id="21" name="Shape 18"/>
           <p:cNvSpPr/>
           <p:nvPr/>
         </p:nvSpPr>
@@ -7779,7 +7789,7 @@
       </p:sp>
       <p:sp>
         <p:nvSpPr>
-          <p:cNvPr id="21" name="Shape 19"/>
+          <p:cNvPr id="22" name="Shape 19"/>
           <p:cNvSpPr/>
           <p:nvPr/>
         </p:nvSpPr>
@@ -7806,7 +7816,7 @@
       </p:sp>
       <p:sp>
         <p:nvSpPr>
-          <p:cNvPr id="22" name="Text 20"/>
+          <p:cNvPr id="23" name="Text 20"/>
           <p:cNvSpPr/>
           <p:nvPr/>
         </p:nvSpPr>
@@ -7845,7 +7855,7 @@
       </p:sp>
       <p:sp>
         <p:nvSpPr>
-          <p:cNvPr id="23" name="Shape 21"/>
+          <p:cNvPr id="24" name="Shape 21"/>
           <p:cNvSpPr/>
           <p:nvPr/>
         </p:nvSpPr>
@@ -7870,7 +7880,7 @@
       </p:sp>
       <p:sp>
         <p:nvSpPr>
-          <p:cNvPr id="24" name="Shape 22"/>
+          <p:cNvPr id="25" name="Shape 22"/>
           <p:cNvSpPr/>
           <p:nvPr/>
         </p:nvSpPr>
@@ -7897,7 +7907,7 @@
       </p:sp>
       <p:sp>
         <p:nvSpPr>
-          <p:cNvPr id="25" name="Text 23"/>
+          <p:cNvPr id="26" name="Text 23"/>
           <p:cNvSpPr/>
           <p:nvPr/>
         </p:nvSpPr>
@@ -7936,7 +7946,7 @@
       </p:sp>
       <p:sp>
         <p:nvSpPr>
-          <p:cNvPr id="26" name="Shape 24"/>
+          <p:cNvPr id="27" name="Shape 24"/>
           <p:cNvSpPr/>
           <p:nvPr/>
         </p:nvSpPr>
@@ -7961,7 +7971,7 @@
       </p:sp>
       <p:sp>
         <p:nvSpPr>
-          <p:cNvPr id="27" name="Shape 25"/>
+          <p:cNvPr id="28" name="Shape 25"/>
           <p:cNvSpPr/>
           <p:nvPr/>
         </p:nvSpPr>
@@ -7988,7 +7998,7 @@
       </p:sp>
       <p:sp>
         <p:nvSpPr>
-          <p:cNvPr id="28" name="Text 26"/>
+          <p:cNvPr id="29" name="Text 26"/>
           <p:cNvSpPr/>
           <p:nvPr/>
         </p:nvSpPr>
@@ -8027,7 +8037,7 @@
       </p:sp>
       <p:sp>
         <p:nvSpPr>
-          <p:cNvPr id="29" name="Shape 27"/>
+          <p:cNvPr id="30" name="Shape 27"/>
           <p:cNvSpPr/>
           <p:nvPr/>
         </p:nvSpPr>
@@ -8052,7 +8062,7 @@
       </p:sp>
       <p:sp>
         <p:nvSpPr>
-          <p:cNvPr id="30" name="Shape 28"/>
+          <p:cNvPr id="31" name="Shape 28"/>
           <p:cNvSpPr/>
           <p:nvPr/>
         </p:nvSpPr>
@@ -8079,7 +8089,7 @@
       </p:sp>
       <p:sp>
         <p:nvSpPr>
-          <p:cNvPr id="31" name="Text 29"/>
+          <p:cNvPr id="32" name="Text 29"/>
           <p:cNvSpPr/>
           <p:nvPr/>
         </p:nvSpPr>
@@ -8118,7 +8128,7 @@
       </p:sp>
       <p:sp>
         <p:nvSpPr>
-          <p:cNvPr id="32" name="Shape 30"/>
+          <p:cNvPr id="33" name="Shape 30"/>
           <p:cNvSpPr/>
           <p:nvPr/>
         </p:nvSpPr>
@@ -8145,7 +8155,7 @@
       </p:sp>
       <p:sp>
         <p:nvSpPr>
-          <p:cNvPr id="33" name="Text 31"/>
+          <p:cNvPr id="34" name="Text 31"/>
           <p:cNvSpPr/>
           <p:nvPr/>
         </p:nvSpPr>
@@ -8184,7 +8194,7 @@
       </p:sp>
       <p:sp>
         <p:nvSpPr>
-          <p:cNvPr id="34" name="Text 32"/>
+          <p:cNvPr id="35" name="Text 32"/>
           <p:cNvSpPr/>
           <p:nvPr/>
         </p:nvSpPr>
@@ -8223,7 +8233,7 @@
       </p:sp>
       <p:sp>
         <p:nvSpPr>
-          <p:cNvPr id="35" name="Shape 33"/>
+          <p:cNvPr id="36" name="Shape 33"/>
           <p:cNvSpPr/>
           <p:nvPr/>
         </p:nvSpPr>
@@ -8250,7 +8260,7 @@
       </p:sp>
       <p:sp>
         <p:nvSpPr>
-          <p:cNvPr id="36" name="Text 34"/>
+          <p:cNvPr id="37" name="Text 34"/>
           <p:cNvSpPr/>
           <p:nvPr/>
         </p:nvSpPr>
@@ -8289,7 +8299,7 @@
       </p:sp>
       <p:sp>
         <p:nvSpPr>
-          <p:cNvPr id="37" name="Text 35"/>
+          <p:cNvPr id="38" name="Text 35"/>
           <p:cNvSpPr/>
           <p:nvPr/>
         </p:nvSpPr>
@@ -8545,7 +8555,7 @@
       </p:sp>
       <p:sp>
         <p:nvSpPr>
-          <p:cNvPr id="7" name="Text 5"/>
+          <p:cNvPr id="8" name="Text 5"/>
           <p:cNvSpPr/>
           <p:nvPr/>
         </p:nvSpPr>
@@ -8584,7 +8594,7 @@
       </p:sp>
       <p:sp>
         <p:nvSpPr>
-          <p:cNvPr id="8" name="Text 6"/>
+          <p:cNvPr id="9" name="Text 6"/>
           <p:cNvSpPr/>
           <p:nvPr/>
         </p:nvSpPr>
@@ -8623,7 +8633,7 @@
       </p:sp>
       <p:sp>
         <p:nvSpPr>
-          <p:cNvPr id="9" name="Shape 7"/>
+          <p:cNvPr id="10" name="Shape 7"/>
           <p:cNvSpPr/>
           <p:nvPr/>
         </p:nvSpPr>
@@ -8648,7 +8658,7 @@
       </p:sp>
       <p:sp>
         <p:nvSpPr>
-          <p:cNvPr id="10" name="Text 8"/>
+          <p:cNvPr id="11" name="Text 8"/>
           <p:cNvSpPr/>
           <p:nvPr/>
         </p:nvSpPr>
@@ -8687,7 +8697,7 @@
       </p:sp>
       <p:sp>
         <p:nvSpPr>
-          <p:cNvPr id="11" name="Text 9"/>
+          <p:cNvPr id="12" name="Text 9"/>
           <p:cNvSpPr/>
           <p:nvPr/>
         </p:nvSpPr>
@@ -8726,7 +8736,7 @@
       </p:sp>
       <p:sp>
         <p:nvSpPr>
-          <p:cNvPr id="12" name="Shape 10"/>
+          <p:cNvPr id="13" name="Shape 10"/>
           <p:cNvSpPr/>
           <p:nvPr/>
         </p:nvSpPr>
@@ -8753,7 +8763,7 @@
       </p:sp>
       <p:sp>
         <p:nvSpPr>
-          <p:cNvPr id="13" name="Text 11"/>
+          <p:cNvPr id="14" name="Text 11"/>
           <p:cNvSpPr/>
           <p:nvPr/>
         </p:nvSpPr>
@@ -8792,7 +8802,7 @@
       </p:sp>
       <p:sp>
         <p:nvSpPr>
-          <p:cNvPr id="14" name="Text 12"/>
+          <p:cNvPr id="15" name="Text 12"/>
           <p:cNvSpPr/>
           <p:nvPr/>
         </p:nvSpPr>
@@ -8831,7 +8841,7 @@
       </p:sp>
       <p:sp>
         <p:nvSpPr>
-          <p:cNvPr id="15" name="Shape 13"/>
+          <p:cNvPr id="16" name="Shape 13"/>
           <p:cNvSpPr/>
           <p:nvPr/>
         </p:nvSpPr>
@@ -8858,7 +8868,7 @@
       </p:sp>
       <p:sp>
         <p:nvSpPr>
-          <p:cNvPr id="16" name="Text 14"/>
+          <p:cNvPr id="17" name="Text 14"/>
           <p:cNvSpPr/>
           <p:nvPr/>
         </p:nvSpPr>
@@ -8897,7 +8907,7 @@
       </p:sp>
       <p:sp>
         <p:nvSpPr>
-          <p:cNvPr id="17" name="Text 15"/>
+          <p:cNvPr id="18" name="Text 15"/>
           <p:cNvSpPr/>
           <p:nvPr/>
         </p:nvSpPr>
@@ -8936,7 +8946,7 @@
       </p:sp>
       <p:sp>
         <p:nvSpPr>
-          <p:cNvPr id="18" name="Shape 16"/>
+          <p:cNvPr id="19" name="Shape 16"/>
           <p:cNvSpPr/>
           <p:nvPr/>
         </p:nvSpPr>
@@ -8963,7 +8973,7 @@
       </p:sp>
       <p:sp>
         <p:nvSpPr>
-          <p:cNvPr id="19" name="Text 17"/>
+          <p:cNvPr id="20" name="Text 17"/>
           <p:cNvSpPr/>
           <p:nvPr/>
         </p:nvSpPr>
@@ -9002,7 +9012,7 @@
       </p:sp>
       <p:sp>
         <p:nvSpPr>
-          <p:cNvPr id="20" name="Text 18"/>
+          <p:cNvPr id="21" name="Text 18"/>
           <p:cNvSpPr/>
           <p:nvPr/>
         </p:nvSpPr>
@@ -9041,7 +9051,7 @@
       </p:sp>
       <p:sp>
         <p:nvSpPr>
-          <p:cNvPr id="21" name="Shape 19"/>
+          <p:cNvPr id="22" name="Shape 19"/>
           <p:cNvSpPr/>
           <p:nvPr/>
         </p:nvSpPr>
@@ -9068,7 +9078,7 @@
       </p:sp>
       <p:sp>
         <p:nvSpPr>
-          <p:cNvPr id="22" name="Text 20"/>
+          <p:cNvPr id="23" name="Text 20"/>
           <p:cNvSpPr/>
           <p:nvPr/>
         </p:nvSpPr>
@@ -9107,7 +9117,7 @@
       </p:sp>
       <p:sp>
         <p:nvSpPr>
-          <p:cNvPr id="23" name="Text 21"/>
+          <p:cNvPr id="24" name="Text 21"/>
           <p:cNvSpPr/>
           <p:nvPr/>
         </p:nvSpPr>
@@ -9146,7 +9156,7 @@
       </p:sp>
       <p:sp>
         <p:nvSpPr>
-          <p:cNvPr id="24" name="Shape 22"/>
+          <p:cNvPr id="25" name="Shape 22"/>
           <p:cNvSpPr/>
           <p:nvPr/>
         </p:nvSpPr>
@@ -9171,7 +9181,7 @@
       </p:sp>
       <p:sp>
         <p:nvSpPr>
-          <p:cNvPr id="25" name="Shape 23"/>
+          <p:cNvPr id="26" name="Shape 23"/>
           <p:cNvSpPr/>
           <p:nvPr/>
         </p:nvSpPr>
@@ -9196,7 +9206,7 @@
       </p:sp>
       <p:sp>
         <p:nvSpPr>
-          <p:cNvPr id="26" name="Shape 24"/>
+          <p:cNvPr id="27" name="Shape 24"/>
           <p:cNvSpPr/>
           <p:nvPr/>
         </p:nvSpPr>
@@ -9221,7 +9231,7 @@
       </p:sp>
       <p:sp>
         <p:nvSpPr>
-          <p:cNvPr id="27" name="Shape 25"/>
+          <p:cNvPr id="28" name="Shape 25"/>
           <p:cNvSpPr/>
           <p:nvPr/>
         </p:nvSpPr>
@@ -9246,7 +9256,7 @@
       </p:sp>
       <p:sp>
         <p:nvSpPr>
-          <p:cNvPr id="28" name="Shape 26"/>
+          <p:cNvPr id="29" name="Shape 26"/>
           <p:cNvSpPr/>
           <p:nvPr/>
         </p:nvSpPr>
@@ -9273,7 +9283,7 @@
       </p:sp>
       <p:sp>
         <p:nvSpPr>
-          <p:cNvPr id="29" name="Text 27"/>
+          <p:cNvPr id="30" name="Text 27"/>
           <p:cNvSpPr/>
           <p:nvPr/>
         </p:nvSpPr>
@@ -9312,7 +9322,7 @@
       </p:sp>
       <p:sp>
         <p:nvSpPr>
-          <p:cNvPr id="30" name="Text 28"/>
+          <p:cNvPr id="31" name="Text 28"/>
           <p:cNvSpPr/>
           <p:nvPr/>
         </p:nvSpPr>
@@ -9568,7 +9578,7 @@
       </p:sp>
       <p:sp>
         <p:nvSpPr>
-          <p:cNvPr id="7" name="Text 5"/>
+          <p:cNvPr id="8" name="Text 5"/>
           <p:cNvSpPr/>
           <p:nvPr/>
         </p:nvSpPr>
@@ -9607,7 +9617,7 @@
       </p:sp>
       <p:sp>
         <p:nvSpPr>
-          <p:cNvPr id="8" name="Text 6"/>
+          <p:cNvPr id="9" name="Text 6"/>
           <p:cNvSpPr/>
           <p:nvPr/>
         </p:nvSpPr>
@@ -9646,7 +9656,7 @@
       </p:sp>
       <p:sp>
         <p:nvSpPr>
-          <p:cNvPr id="9" name="Shape 7"/>
+          <p:cNvPr id="10" name="Shape 7"/>
           <p:cNvSpPr/>
           <p:nvPr/>
         </p:nvSpPr>
@@ -9673,7 +9683,7 @@
       </p:sp>
       <p:sp>
         <p:nvSpPr>
-          <p:cNvPr id="10" name="Text 8"/>
+          <p:cNvPr id="11" name="Text 8"/>
           <p:cNvSpPr/>
           <p:nvPr/>
         </p:nvSpPr>
@@ -9712,7 +9722,7 @@
       </p:sp>
       <p:sp>
         <p:nvSpPr>
-          <p:cNvPr id="11" name="Shape 9"/>
+          <p:cNvPr id="12" name="Shape 9"/>
           <p:cNvSpPr/>
           <p:nvPr/>
         </p:nvSpPr>
@@ -9739,7 +9749,7 @@
       </p:sp>
       <p:sp>
         <p:nvSpPr>
-          <p:cNvPr id="12" name="Text 10"/>
+          <p:cNvPr id="13" name="Text 10"/>
           <p:cNvSpPr/>
           <p:nvPr/>
         </p:nvSpPr>
@@ -9778,7 +9788,7 @@
       </p:sp>
       <p:sp>
         <p:nvSpPr>
-          <p:cNvPr id="13" name="Shape 11"/>
+          <p:cNvPr id="14" name="Shape 11"/>
           <p:cNvSpPr/>
           <p:nvPr/>
         </p:nvSpPr>
@@ -9805,7 +9815,7 @@
       </p:sp>
       <p:sp>
         <p:nvSpPr>
-          <p:cNvPr id="14" name="Text 12"/>
+          <p:cNvPr id="15" name="Text 12"/>
           <p:cNvSpPr/>
           <p:nvPr/>
         </p:nvSpPr>
@@ -9844,7 +9854,7 @@
       </p:sp>
       <p:sp>
         <p:nvSpPr>
-          <p:cNvPr id="15" name="Shape 13"/>
+          <p:cNvPr id="16" name="Shape 13"/>
           <p:cNvSpPr/>
           <p:nvPr/>
         </p:nvSpPr>
@@ -9871,7 +9881,7 @@
       </p:sp>
       <p:sp>
         <p:nvSpPr>
-          <p:cNvPr id="16" name="Text 14"/>
+          <p:cNvPr id="17" name="Text 14"/>
           <p:cNvSpPr/>
           <p:nvPr/>
         </p:nvSpPr>
@@ -9910,7 +9920,7 @@
       </p:sp>
       <p:sp>
         <p:nvSpPr>
-          <p:cNvPr id="17" name="Shape 15"/>
+          <p:cNvPr id="18" name="Shape 15"/>
           <p:cNvSpPr/>
           <p:nvPr/>
         </p:nvSpPr>
@@ -9937,7 +9947,7 @@
       </p:sp>
       <p:sp>
         <p:nvSpPr>
-          <p:cNvPr id="18" name="Text 16"/>
+          <p:cNvPr id="19" name="Text 16"/>
           <p:cNvSpPr/>
           <p:nvPr/>
         </p:nvSpPr>
@@ -9976,7 +9986,7 @@
       </p:sp>
       <p:sp>
         <p:nvSpPr>
-          <p:cNvPr id="19" name="Text 17"/>
+          <p:cNvPr id="20" name="Text 17"/>
           <p:cNvSpPr/>
           <p:nvPr/>
         </p:nvSpPr>
@@ -10015,7 +10025,7 @@
       </p:sp>
       <p:sp>
         <p:nvSpPr>
-          <p:cNvPr id="20" name="Text 18"/>
+          <p:cNvPr id="21" name="Text 18"/>
           <p:cNvSpPr/>
           <p:nvPr/>
         </p:nvSpPr>
@@ -10054,7 +10064,7 @@
       </p:sp>
       <p:sp>
         <p:nvSpPr>
-          <p:cNvPr id="21" name="Text 19"/>
+          <p:cNvPr id="22" name="Text 19"/>
           <p:cNvSpPr/>
           <p:nvPr/>
         </p:nvSpPr>
@@ -10310,7 +10320,7 @@
       </p:sp>
       <p:sp>
         <p:nvSpPr>
-          <p:cNvPr id="7" name="Text 5"/>
+          <p:cNvPr id="8" name="Text 5"/>
           <p:cNvSpPr/>
           <p:nvPr/>
         </p:nvSpPr>
@@ -10349,7 +10359,7 @@
       </p:sp>
       <p:sp>
         <p:nvSpPr>
-          <p:cNvPr id="8" name="Text 6"/>
+          <p:cNvPr id="9" name="Text 6"/>
           <p:cNvSpPr/>
           <p:nvPr/>
         </p:nvSpPr>
@@ -10388,7 +10398,7 @@
       </p:sp>
       <p:sp>
         <p:nvSpPr>
-          <p:cNvPr id="9" name="Shape 7"/>
+          <p:cNvPr id="10" name="Shape 7"/>
           <p:cNvSpPr/>
           <p:nvPr/>
         </p:nvSpPr>
@@ -10415,7 +10425,7 @@
       </p:sp>
       <p:sp>
         <p:nvSpPr>
-          <p:cNvPr id="10" name="Text 8"/>
+          <p:cNvPr id="11" name="Text 8"/>
           <p:cNvSpPr/>
           <p:nvPr/>
         </p:nvSpPr>
@@ -10454,7 +10464,7 @@
       </p:sp>
       <p:sp>
         <p:nvSpPr>
-          <p:cNvPr id="11" name="Text 9"/>
+          <p:cNvPr id="12" name="Text 9"/>
           <p:cNvSpPr/>
           <p:nvPr/>
         </p:nvSpPr>
@@ -10527,7 +10537,7 @@
       </p:sp>
       <p:sp>
         <p:nvSpPr>
-          <p:cNvPr id="12" name="Text 10"/>
+          <p:cNvPr id="13" name="Text 10"/>
           <p:cNvSpPr/>
           <p:nvPr/>
         </p:nvSpPr>
@@ -10566,7 +10576,7 @@
       </p:sp>
       <p:sp>
         <p:nvSpPr>
-          <p:cNvPr id="13" name="Shape 11"/>
+          <p:cNvPr id="14" name="Shape 11"/>
           <p:cNvSpPr/>
           <p:nvPr/>
         </p:nvSpPr>
@@ -10593,7 +10603,7 @@
       </p:sp>
       <p:sp>
         <p:nvSpPr>
-          <p:cNvPr id="14" name="Text 12"/>
+          <p:cNvPr id="15" name="Text 12"/>
           <p:cNvSpPr/>
           <p:nvPr/>
         </p:nvSpPr>
@@ -10632,7 +10642,7 @@
       </p:sp>
       <p:sp>
         <p:nvSpPr>
-          <p:cNvPr id="15" name="Text 13"/>
+          <p:cNvPr id="16" name="Text 13"/>
           <p:cNvSpPr/>
           <p:nvPr/>
         </p:nvSpPr>
@@ -10705,7 +10715,7 @@
       </p:sp>
       <p:sp>
         <p:nvSpPr>
-          <p:cNvPr id="16" name="Text 14"/>
+          <p:cNvPr id="17" name="Text 14"/>
           <p:cNvSpPr/>
           <p:nvPr/>
         </p:nvSpPr>
@@ -10744,7 +10754,7 @@
       </p:sp>
       <p:sp>
         <p:nvSpPr>
-          <p:cNvPr id="17" name="Shape 15"/>
+          <p:cNvPr id="18" name="Shape 15"/>
           <p:cNvSpPr/>
           <p:nvPr/>
         </p:nvSpPr>
@@ -10771,7 +10781,7 @@
       </p:sp>
       <p:sp>
         <p:nvSpPr>
-          <p:cNvPr id="18" name="Text 16"/>
+          <p:cNvPr id="19" name="Text 16"/>
           <p:cNvSpPr/>
           <p:nvPr/>
         </p:nvSpPr>
@@ -10810,7 +10820,7 @@
       </p:sp>
       <p:sp>
         <p:nvSpPr>
-          <p:cNvPr id="19" name="Text 17"/>
+          <p:cNvPr id="20" name="Text 17"/>
           <p:cNvSpPr/>
           <p:nvPr/>
         </p:nvSpPr>
@@ -10849,7 +10859,7 @@
       </p:sp>
       <p:sp>
         <p:nvSpPr>
-          <p:cNvPr id="20" name="Text 18"/>
+          <p:cNvPr id="21" name="Text 18"/>
           <p:cNvSpPr/>
           <p:nvPr/>
         </p:nvSpPr>

</xml_diff>